<commit_message>
Slides 7 and 11: Claude planner and current verification numbers
Slide 7's last point described only the optional Ollama route; it now names the Claude planner and its validation. Slide 11 now gives this branch's test count (936 passed, 4 skipped) and the live Claude checks (16/16, 24/24) instead of the snapshot count and the single Qwen request. Only those three text runs changed; each new sentence is no longer than the one it replaces, and the deck passes OOXML validation against the original.

Co-Authored-By: Claude Opus 5.5 <noreply@anthropic.com>
</commit_message>
<xml_diff>
--- a/docs/presentation/AROL_Telemetry_Project_Review.pptx
+++ b/docs/presentation/AROL_Telemetry_Project_Review.pptx
@@ -4334,7 +4334,7 @@
                 <a:ea typeface="Liberation Sans"/>
                 <a:cs typeface="Liberation Sans"/>
               </a:rPr>
-              <a:t>Uploaded source snapshot: 856 tests passed; 4 standalone-repo tests skipped.</a:t>
+              <a:t>Current branch: 936 tests passed; 4 standalone-repo tests skipped.</a:t>
             </a:r>
           </a:p>
         </p:txBody>
@@ -4535,7 +4535,7 @@
                 <a:ea typeface="Liberation Sans"/>
                 <a:cs typeface="Liberation Sans"/>
               </a:rPr>
-              <a:t>A scoped live Qwen request matched the independent torque calculation.</a:t>
+              <a:t>Live Claude checks: 16/16 phrasings, 24/24 end-to-end questions.</a:t>
             </a:r>
           </a:p>
         </p:txBody>
@@ -8251,7 +8251,7 @@
                 <a:ea typeface="Liberation Sans"/>
                 <a:cs typeface="Liberation Sans"/>
               </a:rPr>
-              <a:t>Optional Ollama routing validates a model proposal against the same scope.</a:t>
+              <a:t>The Claude planner maps everyday wording to tools; proposals are validated.</a:t>
             </a:r>
           </a:p>
         </p:txBody>

</xml_diff>